<commit_message>
M3: sun-synchronous orbit — Sun marker, J2 nodal precession, SSO preset
tut3 now draws the Sun's direction (advancing 360deg/365.25d on the shared sim
clock) and, with auto-move on, precesses the RAAN at the real J2 nodal rate
Om-dot = -(3/2) J2 (Re/p)^2 n cos(i) (nodal only; the Molniya note already covers
the frozen apsides at 63.4). A corner HUD reads node-Sun angle + precession rate
and flags the sun-synchronous lock. New preset: 700 km, i=98.2 (retrograde),
+0.987 deg/day vs the Sun's +0.9856 - verified by executing the shipped
raanDotDegDay() with stubbed sliders (ISS -4.95 deg/day, Molniya -0.148).
RAAN animation uses a continuous animRaan state (same slider-snap trap as
animNu); RAAN slider step 1 -> 0.1.

Worksheet 3: new d4 task (the orbit that tells time) + quiz. Instructor guide
M3 section + learning goal; module3.pptx slides 6-7; guide.html regenerated.
</commit_message>
<xml_diff>
--- a/slides/module3.pptx
+++ b/slides/module3.pptx
@@ -6937,7 +6937,7 @@
                 </a:solidFill>
                 <a:latin typeface="Arial"/>
               </a:rPr>
-              <a:t>A highly stretched orbit whose apogee dwells over high latitudes GEO can't serve — the Soviet comms trick. Tundra is its 24-hour cousin.</a:t>
+              <a:t>Two designer orbits from one perturbation: J2 parks Molniya’s apogee over the north — and precesses a 98.2° sun-synchronous orbit to track the Sun at +0.9856°/day, same lighting every pass.</a:t>
             </a:r>
           </a:p>
         </p:txBody>
@@ -7820,7 +7820,7 @@
                 </a:solidFill>
                 <a:latin typeface="Arial"/>
               </a:rPr>
-              <a:t>Invent the Molniya orbit by trial and error — then load the real ISS, GPS, and Tundra.</a:t>
+              <a:t>Invent Molniya by trial and error — then ride a sun-synchronous orbit and watch its plane track the Sun.</a:t>
             </a:r>
           </a:p>
         </p:txBody>

</xml_diff>